<commit_message>
Delivered column: name shipped features; merge metrics with trend
Reworked slide 1 so the DELIVERED · Apr–Jun'26 column lists the product
stories / features shipped (named), and the trend chart now sits together
with its metric deltas in a combined METRICS & TREND column.

Feature names are indicative pending Linear authorization (noted on-slide
and in README).

Co-Authored-By: Claude Opus 4.8 <noreply@anthropic.com>
Claude-Session: https://claude.ai/code/session_011FHA995qAv36qVDDkav6FX
</commit_message>
<xml_diff>
--- a/board-review/TML_Review__CM__AprMayJun_2026.pptx
+++ b/board-review/TML_Review__CM__AprMayJun_2026.pptx
@@ -13073,7 +13073,7 @@
         <p:spPr>
           <a:xfrm>
             <a:off x="274320" y="731520"/>
-            <a:ext cx="1463040" cy="219456"/>
+            <a:ext cx="1389888" cy="219456"/>
           </a:xfrm>
           <a:prstGeom prst="roundRect">
             <a:avLst>
@@ -13119,7 +13119,7 @@
         <p:spPr>
           <a:xfrm>
             <a:off x="274320" y="731520"/>
-            <a:ext cx="1463040" cy="219456"/>
+            <a:ext cx="1389888" cy="219456"/>
           </a:xfrm>
           <a:prstGeom prst="rect">
             <a:avLst/>
@@ -13163,8 +13163,8 @@
         </p:nvSpPr>
         <p:spPr>
           <a:xfrm>
-            <a:off x="1783080" y="731520"/>
-            <a:ext cx="2286000" cy="219456"/>
+            <a:off x="1709928" y="731520"/>
+            <a:ext cx="2103120" cy="219456"/>
           </a:xfrm>
           <a:prstGeom prst="roundRect">
             <a:avLst>
@@ -13209,8 +13209,8 @@
         </p:nvSpPr>
         <p:spPr>
           <a:xfrm>
-            <a:off x="1783080" y="731520"/>
-            <a:ext cx="2286000" cy="219456"/>
+            <a:off x="1709928" y="731520"/>
+            <a:ext cx="2103120" cy="219456"/>
           </a:xfrm>
           <a:prstGeom prst="rect">
             <a:avLst/>
@@ -13254,8 +13254,8 @@
         </p:nvSpPr>
         <p:spPr>
           <a:xfrm>
-            <a:off x="4114800" y="731520"/>
-            <a:ext cx="2121408" cy="219456"/>
+            <a:off x="3858768" y="731520"/>
+            <a:ext cx="2871216" cy="219456"/>
           </a:xfrm>
           <a:prstGeom prst="roundRect">
             <a:avLst>
@@ -13300,8 +13300,8 @@
         </p:nvSpPr>
         <p:spPr>
           <a:xfrm>
-            <a:off x="4114800" y="731520"/>
-            <a:ext cx="2121408" cy="219456"/>
+            <a:off x="3858768" y="731520"/>
+            <a:ext cx="2871216" cy="219456"/>
           </a:xfrm>
           <a:prstGeom prst="rect">
             <a:avLst/>
@@ -13332,7 +13332,7 @@
                 </a:solidFill>
                 <a:latin typeface="Manrope"/>
               </a:rPr>
-              <a:t>TREND (JAN–JUN'26)</a:t>
+              <a:t>METRICS &amp; TREND (JAN–JUN'26)</a:t>
             </a:r>
           </a:p>
         </p:txBody>
@@ -13345,8 +13345,8 @@
         </p:nvSpPr>
         <p:spPr>
           <a:xfrm>
-            <a:off x="6281928" y="731520"/>
-            <a:ext cx="2569464" cy="219456"/>
+            <a:off x="6775704" y="731520"/>
+            <a:ext cx="2075688" cy="219456"/>
           </a:xfrm>
           <a:prstGeom prst="roundRect">
             <a:avLst>
@@ -13391,8 +13391,8 @@
         </p:nvSpPr>
         <p:spPr>
           <a:xfrm>
-            <a:off x="6281928" y="731520"/>
-            <a:ext cx="2569464" cy="219456"/>
+            <a:off x="6775704" y="731520"/>
+            <a:ext cx="2075688" cy="219456"/>
           </a:xfrm>
           <a:prstGeom prst="rect">
             <a:avLst/>
@@ -13437,7 +13437,7 @@
         <p:spPr>
           <a:xfrm>
             <a:off x="274320" y="987552"/>
-            <a:ext cx="1463040" cy="749808"/>
+            <a:ext cx="1389888" cy="749808"/>
           </a:xfrm>
           <a:prstGeom prst="roundRect">
             <a:avLst>
@@ -13484,8 +13484,8 @@
         </p:nvSpPr>
         <p:spPr>
           <a:xfrm>
-            <a:off x="1783080" y="987552"/>
-            <a:ext cx="2286000" cy="749808"/>
+            <a:off x="1709928" y="987552"/>
+            <a:ext cx="2103120" cy="749808"/>
           </a:xfrm>
           <a:prstGeom prst="roundRect">
             <a:avLst>
@@ -13532,8 +13532,8 @@
         </p:nvSpPr>
         <p:spPr>
           <a:xfrm>
-            <a:off x="4114800" y="987552"/>
-            <a:ext cx="2121408" cy="749808"/>
+            <a:off x="3858768" y="987552"/>
+            <a:ext cx="2871216" cy="749808"/>
           </a:xfrm>
           <a:prstGeom prst="roundRect">
             <a:avLst>
@@ -13580,8 +13580,8 @@
         </p:nvSpPr>
         <p:spPr>
           <a:xfrm>
-            <a:off x="6281928" y="987552"/>
-            <a:ext cx="2569464" cy="749808"/>
+            <a:off x="6775704" y="987552"/>
+            <a:ext cx="2075688" cy="749808"/>
           </a:xfrm>
           <a:prstGeom prst="roundRect">
             <a:avLst>
@@ -13629,7 +13629,7 @@
         <p:spPr>
           <a:xfrm>
             <a:off x="274320" y="987552"/>
-            <a:ext cx="1463040" cy="749808"/>
+            <a:ext cx="1389888" cy="749808"/>
           </a:xfrm>
           <a:prstGeom prst="rect">
             <a:avLst/>
@@ -13695,8 +13695,8 @@
         </p:nvSpPr>
         <p:spPr>
           <a:xfrm>
-            <a:off x="1783080" y="987552"/>
-            <a:ext cx="2286000" cy="749808"/>
+            <a:off x="1709928" y="987552"/>
+            <a:ext cx="2103120" cy="749808"/>
           </a:xfrm>
           <a:prstGeom prst="rect">
             <a:avLst/>
@@ -13727,16 +13727,7 @@
                 </a:solidFill>
                 <a:latin typeface="Manrope"/>
               </a:rPr>
-              <a:t>DAU 178 → </a:t>
-            </a:r>
-            <a:r>
-              <a:rPr b="1" sz="650">
-                <a:solidFill>
-                  <a:srgbClr val="1C6B2D"/>
-                </a:solidFill>
-                <a:latin typeface="Manrope"/>
-              </a:rPr>
-              <a:t>252</a:t>
+              <a:t>• </a:t>
             </a:r>
             <a:r>
               <a:rPr b="0" sz="650">
@@ -13745,7 +13736,7 @@
                 </a:solidFill>
                 <a:latin typeface="Manrope"/>
               </a:rPr>
-              <a:t> (+42%); crossed 200</a:t>
+              <a:t>Load discovery &amp; experience revamp</a:t>
             </a:r>
           </a:p>
           <a:p>
@@ -13767,7 +13758,16 @@
                 </a:solidFill>
                 <a:latin typeface="Manrope"/>
               </a:rPr>
-              <a:t>Installs 1,449 → 1,935; MAU 1,027 → 1,325</a:t>
+              <a:t>• </a:t>
+            </a:r>
+            <a:r>
+              <a:rPr b="0" sz="650">
+                <a:solidFill>
+                  <a:srgbClr val="111827"/>
+                </a:solidFill>
+                <a:latin typeface="Manrope"/>
+              </a:rPr>
+              <a:t>In-app payment visibility</a:t>
             </a:r>
           </a:p>
           <a:p>
@@ -13789,7 +13789,16 @@
                 </a:solidFill>
                 <a:latin typeface="Manrope"/>
               </a:rPr>
-              <a:t>Stickiness 17.3% → 19.0%</a:t>
+              <a:t>• </a:t>
+            </a:r>
+            <a:r>
+              <a:rPr b="0" sz="650">
+                <a:solidFill>
+                  <a:srgbClr val="111827"/>
+                </a:solidFill>
+                <a:latin typeface="Manrope"/>
+              </a:rPr>
+              <a:t>Bid &amp; trip status surfacing</a:t>
             </a:r>
           </a:p>
         </p:txBody>
@@ -13810,8 +13819,8 @@
         </p:blipFill>
         <p:spPr>
           <a:xfrm>
-            <a:off x="4178808" y="1023579"/>
-            <a:ext cx="1993392" cy="677753"/>
+            <a:off x="3904487" y="1095085"/>
+            <a:ext cx="1572768" cy="534741"/>
           </a:xfrm>
           <a:prstGeom prst="rect">
             <a:avLst/>
@@ -13826,8 +13835,115 @@
         </p:nvSpPr>
         <p:spPr>
           <a:xfrm>
-            <a:off x="6281928" y="987552"/>
-            <a:ext cx="2569464" cy="749808"/>
+            <a:off x="5522976" y="987552"/>
+            <a:ext cx="1170432" cy="749808"/>
+          </a:xfrm>
+          <a:prstGeom prst="rect">
+            <a:avLst/>
+          </a:prstGeom>
+          <a:noFill/>
+        </p:spPr>
+        <p:txBody>
+          <a:bodyPr wrap="square" anchor="ctr" lIns="27432" rIns="27432" tIns="9144" bIns="9144">
+            <a:spAutoFit/>
+          </a:bodyPr>
+          <a:lstStyle/>
+          <a:p>
+            <a:pPr algn="l">
+              <a:lnSpc>
+                <a:spcPct val="100000"/>
+              </a:lnSpc>
+              <a:spcBef>
+                <a:spcPts val="0"/>
+              </a:spcBef>
+              <a:spcAft>
+                <a:spcPts val="150"/>
+              </a:spcAft>
+            </a:pPr>
+            <a:r>
+              <a:rPr b="0" sz="650">
+                <a:solidFill>
+                  <a:srgbClr val="111827"/>
+                </a:solidFill>
+                <a:latin typeface="Manrope"/>
+              </a:rPr>
+              <a:t>DAU 178→</a:t>
+            </a:r>
+            <a:r>
+              <a:rPr b="1" sz="650">
+                <a:solidFill>
+                  <a:srgbClr val="1C6B2D"/>
+                </a:solidFill>
+                <a:latin typeface="Manrope"/>
+              </a:rPr>
+              <a:t>252</a:t>
+            </a:r>
+            <a:r>
+              <a:rPr b="0" sz="650">
+                <a:solidFill>
+                  <a:srgbClr val="111827"/>
+                </a:solidFill>
+                <a:latin typeface="Manrope"/>
+              </a:rPr>
+              <a:t> (+42%)</a:t>
+            </a:r>
+          </a:p>
+          <a:p>
+            <a:pPr algn="l">
+              <a:lnSpc>
+                <a:spcPct val="100000"/>
+              </a:lnSpc>
+              <a:spcBef>
+                <a:spcPts val="0"/>
+              </a:spcBef>
+              <a:spcAft>
+                <a:spcPts val="150"/>
+              </a:spcAft>
+            </a:pPr>
+            <a:r>
+              <a:rPr b="0" sz="650">
+                <a:solidFill>
+                  <a:srgbClr val="111827"/>
+                </a:solidFill>
+                <a:latin typeface="Manrope"/>
+              </a:rPr>
+              <a:t>Installs 1,449→1,935</a:t>
+            </a:r>
+          </a:p>
+          <a:p>
+            <a:pPr algn="l">
+              <a:lnSpc>
+                <a:spcPct val="100000"/>
+              </a:lnSpc>
+              <a:spcBef>
+                <a:spcPts val="0"/>
+              </a:spcBef>
+              <a:spcAft>
+                <a:spcPts val="150"/>
+              </a:spcAft>
+            </a:pPr>
+            <a:r>
+              <a:rPr b="0" sz="650">
+                <a:solidFill>
+                  <a:srgbClr val="111827"/>
+                </a:solidFill>
+                <a:latin typeface="Manrope"/>
+              </a:rPr>
+              <a:t>MAU 1,027→1,325</a:t>
+            </a:r>
+          </a:p>
+        </p:txBody>
+      </p:sp>
+      <p:sp>
+        <p:nvSpPr>
+          <p:cNvPr id="168" name="TextBox 167"/>
+          <p:cNvSpPr txBox="1"/>
+          <p:nvPr/>
+        </p:nvSpPr>
+        <p:spPr>
+          <a:xfrm>
+            <a:off x="6775704" y="987552"/>
+            <a:ext cx="2075688" cy="749808"/>
           </a:xfrm>
           <a:prstGeom prst="rect">
             <a:avLst/>
@@ -13898,7 +14014,7 @@
                 </a:solidFill>
                 <a:latin typeface="Manrope"/>
               </a:rPr>
-              <a:t>Push DAU toward 2,000; better load experience</a:t>
+              <a:t>Push DAU toward 2,000</a:t>
             </a:r>
           </a:p>
           <a:p>
@@ -13929,56 +14045,8 @@
                 </a:solidFill>
                 <a:latin typeface="Manrope"/>
               </a:rPr>
-              <a:t>Lift WAU (582→747) &amp; cut uninstalls</a:t>
+              <a:t>Lift WAU (582→747), cut uninstalls</a:t>
             </a:r>
-          </a:p>
-        </p:txBody>
-      </p:sp>
-      <p:sp>
-        <p:nvSpPr>
-          <p:cNvPr id="168" name="Rounded Rectangle 167"/>
-          <p:cNvSpPr/>
-          <p:nvPr/>
-        </p:nvSpPr>
-        <p:spPr>
-          <a:xfrm>
-            <a:off x="274320" y="1764792"/>
-            <a:ext cx="1463040" cy="749808"/>
-          </a:xfrm>
-          <a:prstGeom prst="roundRect">
-            <a:avLst>
-              <a:gd name="adj" fmla="val 6000"/>
-            </a:avLst>
-          </a:prstGeom>
-          <a:solidFill>
-            <a:srgbClr val="F1FBF5"/>
-          </a:solidFill>
-          <a:ln w="9525">
-            <a:solidFill>
-              <a:srgbClr val="D6DEE8"/>
-            </a:solidFill>
-          </a:ln>
-          <a:effectLst/>
-        </p:spPr>
-        <p:style>
-          <a:lnRef idx="1">
-            <a:schemeClr val="accent1"/>
-          </a:lnRef>
-          <a:fillRef idx="3">
-            <a:schemeClr val="accent1"/>
-          </a:fillRef>
-          <a:effectRef idx="2">
-            <a:schemeClr val="accent1"/>
-          </a:effectRef>
-          <a:fontRef idx="minor">
-            <a:schemeClr val="lt1"/>
-          </a:fontRef>
-        </p:style>
-        <p:txBody>
-          <a:bodyPr rtlCol="0" anchor="ctr"/>
-          <a:lstStyle/>
-          <a:p>
-            <a:pPr algn="ctr"/>
           </a:p>
         </p:txBody>
       </p:sp>
@@ -13990,8 +14058,8 @@
         </p:nvSpPr>
         <p:spPr>
           <a:xfrm>
-            <a:off x="1783080" y="1764792"/>
-            <a:ext cx="2286000" cy="749808"/>
+            <a:off x="274320" y="1764792"/>
+            <a:ext cx="1389888" cy="749808"/>
           </a:xfrm>
           <a:prstGeom prst="roundRect">
             <a:avLst>
@@ -14038,8 +14106,8 @@
         </p:nvSpPr>
         <p:spPr>
           <a:xfrm>
-            <a:off x="4114800" y="1764792"/>
-            <a:ext cx="2121408" cy="749808"/>
+            <a:off x="1709928" y="1764792"/>
+            <a:ext cx="2103120" cy="749808"/>
           </a:xfrm>
           <a:prstGeom prst="roundRect">
             <a:avLst>
@@ -14086,8 +14154,8 @@
         </p:nvSpPr>
         <p:spPr>
           <a:xfrm>
-            <a:off x="6281928" y="1764792"/>
-            <a:ext cx="2569464" cy="749808"/>
+            <a:off x="3858768" y="1764792"/>
+            <a:ext cx="2871216" cy="749808"/>
           </a:xfrm>
           <a:prstGeom prst="roundRect">
             <a:avLst>
@@ -14128,319 +14196,14 @@
       </p:sp>
       <p:sp>
         <p:nvSpPr>
-          <p:cNvPr id="172" name="TextBox 171"/>
-          <p:cNvSpPr txBox="1"/>
-          <p:nvPr/>
-        </p:nvSpPr>
-        <p:spPr>
-          <a:xfrm>
-            <a:off x="274320" y="1764792"/>
-            <a:ext cx="1463040" cy="749808"/>
-          </a:xfrm>
-          <a:prstGeom prst="rect">
-            <a:avLst/>
-          </a:prstGeom>
-          <a:noFill/>
-        </p:spPr>
-        <p:txBody>
-          <a:bodyPr wrap="square" anchor="ctr" lIns="45720" rIns="36576" tIns="9144" bIns="9144">
-            <a:spAutoFit/>
-          </a:bodyPr>
-          <a:lstStyle/>
-          <a:p>
-            <a:pPr algn="l">
-              <a:lnSpc>
-                <a:spcPct val="100000"/>
-              </a:lnSpc>
-              <a:spcBef>
-                <a:spcPts val="0"/>
-              </a:spcBef>
-              <a:spcAft>
-                <a:spcPts val="150"/>
-              </a:spcAft>
-            </a:pPr>
-            <a:r>
-              <a:rPr b="1" sz="800">
-                <a:solidFill>
-                  <a:srgbClr val="111827"/>
-                </a:solidFill>
-                <a:latin typeface="Manrope"/>
-              </a:rPr>
-              <a:t>Improve demand fulfilment to 50%</a:t>
-            </a:r>
-          </a:p>
-          <a:p>
-            <a:pPr algn="l">
-              <a:lnSpc>
-                <a:spcPct val="100000"/>
-              </a:lnSpc>
-              <a:spcBef>
-                <a:spcPts val="0"/>
-              </a:spcBef>
-              <a:spcAft>
-                <a:spcPts val="150"/>
-              </a:spcAft>
-            </a:pPr>
-            <a:r>
-              <a:rPr b="0" sz="630">
-                <a:solidFill>
-                  <a:srgbClr val="5D6675"/>
-                </a:solidFill>
-                <a:latin typeface="Manrope"/>
-              </a:rPr>
-              <a:t>Matching, bid ranges &amp; real-time visibility</a:t>
-            </a:r>
-          </a:p>
-        </p:txBody>
-      </p:sp>
-      <p:sp>
-        <p:nvSpPr>
-          <p:cNvPr id="173" name="TextBox 172"/>
-          <p:cNvSpPr txBox="1"/>
-          <p:nvPr/>
-        </p:nvSpPr>
-        <p:spPr>
-          <a:xfrm>
-            <a:off x="1783080" y="1764792"/>
-            <a:ext cx="2286000" cy="749808"/>
-          </a:xfrm>
-          <a:prstGeom prst="rect">
-            <a:avLst/>
-          </a:prstGeom>
-          <a:noFill/>
-        </p:spPr>
-        <p:txBody>
-          <a:bodyPr wrap="square" anchor="ctr" lIns="45720" rIns="36576" tIns="9144" bIns="9144">
-            <a:spAutoFit/>
-          </a:bodyPr>
-          <a:lstStyle/>
-          <a:p>
-            <a:pPr algn="l">
-              <a:lnSpc>
-                <a:spcPct val="100000"/>
-              </a:lnSpc>
-              <a:spcBef>
-                <a:spcPts val="0"/>
-              </a:spcBef>
-              <a:spcAft>
-                <a:spcPts val="150"/>
-              </a:spcAft>
-            </a:pPr>
-            <a:r>
-              <a:rPr b="0" sz="650">
-                <a:solidFill>
-                  <a:srgbClr val="111827"/>
-                </a:solidFill>
-                <a:latin typeface="Manrope"/>
-              </a:rPr>
-              <a:t>Placeable fulfilment 31% → </a:t>
-            </a:r>
-            <a:r>
-              <a:rPr b="1" sz="650">
-                <a:solidFill>
-                  <a:srgbClr val="1C6B2D"/>
-                </a:solidFill>
-                <a:latin typeface="Manrope"/>
-              </a:rPr>
-              <a:t>43.5%</a:t>
-            </a:r>
-          </a:p>
-          <a:p>
-            <a:pPr algn="l">
-              <a:lnSpc>
-                <a:spcPct val="100000"/>
-              </a:lnSpc>
-              <a:spcBef>
-                <a:spcPts val="0"/>
-              </a:spcBef>
-              <a:spcAft>
-                <a:spcPts val="150"/>
-              </a:spcAft>
-            </a:pPr>
-            <a:r>
-              <a:rPr b="0" sz="650">
-                <a:solidFill>
-                  <a:srgbClr val="111827"/>
-                </a:solidFill>
-                <a:latin typeface="Manrope"/>
-              </a:rPr>
-              <a:t>Bids 670 → 725; unique FOs 211 → 267</a:t>
-            </a:r>
-          </a:p>
-          <a:p>
-            <a:pPr algn="l">
-              <a:lnSpc>
-                <a:spcPct val="100000"/>
-              </a:lnSpc>
-              <a:spcBef>
-                <a:spcPts val="0"/>
-              </a:spcBef>
-              <a:spcAft>
-                <a:spcPts val="150"/>
-              </a:spcAft>
-            </a:pPr>
-            <a:r>
-              <a:rPr b="0" sz="650">
-                <a:solidFill>
-                  <a:srgbClr val="111827"/>
-                </a:solidFill>
-                <a:latin typeface="Manrope"/>
-              </a:rPr>
-              <a:t>Overall fulfilment 11% → 12.5%</a:t>
-            </a:r>
-          </a:p>
-        </p:txBody>
-      </p:sp>
-      <p:pic>
-        <p:nvPicPr>
-          <p:cNvPr id="174" name="Picture 173" descr="c2_fulfil.png"/>
-          <p:cNvPicPr>
-            <a:picLocks noChangeAspect="1"/>
-          </p:cNvPicPr>
-          <p:nvPr/>
-        </p:nvPicPr>
-        <p:blipFill>
-          <a:blip r:embed="rId8"/>
-          <a:stretch>
-            <a:fillRect/>
-          </a:stretch>
-        </p:blipFill>
-        <p:spPr>
-          <a:xfrm>
-            <a:off x="4178808" y="1800819"/>
-            <a:ext cx="1993392" cy="677753"/>
-          </a:xfrm>
-          <a:prstGeom prst="rect">
-            <a:avLst/>
-          </a:prstGeom>
-        </p:spPr>
-      </p:pic>
-      <p:sp>
-        <p:nvSpPr>
-          <p:cNvPr id="175" name="TextBox 174"/>
-          <p:cNvSpPr txBox="1"/>
-          <p:nvPr/>
-        </p:nvSpPr>
-        <p:spPr>
-          <a:xfrm>
-            <a:off x="6281928" y="1764792"/>
-            <a:ext cx="2569464" cy="749808"/>
-          </a:xfrm>
-          <a:prstGeom prst="rect">
-            <a:avLst/>
-          </a:prstGeom>
-          <a:noFill/>
-        </p:spPr>
-        <p:txBody>
-          <a:bodyPr wrap="square" anchor="ctr" lIns="45720" rIns="36576" tIns="9144" bIns="9144">
-            <a:spAutoFit/>
-          </a:bodyPr>
-          <a:lstStyle/>
-          <a:p>
-            <a:pPr algn="l">
-              <a:lnSpc>
-                <a:spcPct val="100000"/>
-              </a:lnSpc>
-              <a:spcBef>
-                <a:spcPts val="0"/>
-              </a:spcBef>
-              <a:spcAft>
-                <a:spcPts val="150"/>
-              </a:spcAft>
-            </a:pPr>
-            <a:r>
-              <a:rPr b="0" sz="650">
-                <a:solidFill>
-                  <a:srgbClr val="111827"/>
-                </a:solidFill>
-                <a:latin typeface="Manrope"/>
-              </a:rPr>
-              <a:t>• </a:t>
-            </a:r>
-            <a:r>
-              <a:rPr b="0" sz="650">
-                <a:solidFill>
-                  <a:srgbClr val="111827"/>
-                </a:solidFill>
-                <a:latin typeface="Manrope"/>
-              </a:rPr>
-              <a:t>Sustain 50% placeable-fulfilment target</a:t>
-            </a:r>
-          </a:p>
-          <a:p>
-            <a:pPr algn="l">
-              <a:lnSpc>
-                <a:spcPct val="100000"/>
-              </a:lnSpc>
-              <a:spcBef>
-                <a:spcPts val="0"/>
-              </a:spcBef>
-              <a:spcAft>
-                <a:spcPts val="150"/>
-              </a:spcAft>
-            </a:pPr>
-            <a:r>
-              <a:rPr b="0" sz="650">
-                <a:solidFill>
-                  <a:srgbClr val="111827"/>
-                </a:solidFill>
-                <a:latin typeface="Manrope"/>
-              </a:rPr>
-              <a:t>• </a:t>
-            </a:r>
-            <a:r>
-              <a:rPr b="0" sz="650">
-                <a:solidFill>
-                  <a:srgbClr val="111827"/>
-                </a:solidFill>
-                <a:latin typeface="Manrope"/>
-              </a:rPr>
-              <a:t>Bid ranges &amp; real-time matching visibility</a:t>
-            </a:r>
-          </a:p>
-          <a:p>
-            <a:pPr algn="l">
-              <a:lnSpc>
-                <a:spcPct val="100000"/>
-              </a:lnSpc>
-              <a:spcBef>
-                <a:spcPts val="0"/>
-              </a:spcBef>
-              <a:spcAft>
-                <a:spcPts val="150"/>
-              </a:spcAft>
-            </a:pPr>
-            <a:r>
-              <a:rPr b="0" sz="650">
-                <a:solidFill>
-                  <a:srgbClr val="111827"/>
-                </a:solidFill>
-                <a:latin typeface="Manrope"/>
-              </a:rPr>
-              <a:t>• </a:t>
-            </a:r>
-            <a:r>
-              <a:rPr b="0" sz="650">
-                <a:solidFill>
-                  <a:srgbClr val="111827"/>
-                </a:solidFill>
-                <a:latin typeface="Manrope"/>
-              </a:rPr>
-              <a:t>Rebuild bid consistency across lanes</a:t>
-            </a:r>
-          </a:p>
-        </p:txBody>
-      </p:sp>
-      <p:sp>
-        <p:nvSpPr>
-          <p:cNvPr id="176" name="Rounded Rectangle 175"/>
+          <p:cNvPr id="172" name="Rounded Rectangle 171"/>
           <p:cNvSpPr/>
           <p:nvPr/>
         </p:nvSpPr>
         <p:spPr>
           <a:xfrm>
-            <a:off x="274320" y="2542032"/>
-            <a:ext cx="1463040" cy="749808"/>
+            <a:off x="6775704" y="1764792"/>
+            <a:ext cx="2075688" cy="749808"/>
           </a:xfrm>
           <a:prstGeom prst="roundRect">
             <a:avLst>
@@ -14448,7 +14211,7 @@
             </a:avLst>
           </a:prstGeom>
           <a:solidFill>
-            <a:srgbClr val="FFFFFF"/>
+            <a:srgbClr val="F1FBF5"/>
           </a:solidFill>
           <a:ln w="9525">
             <a:solidFill>
@@ -14481,49 +14244,422 @@
       </p:sp>
       <p:sp>
         <p:nvSpPr>
-          <p:cNvPr id="177" name="Rounded Rectangle 176"/>
-          <p:cNvSpPr/>
+          <p:cNvPr id="173" name="TextBox 172"/>
+          <p:cNvSpPr txBox="1"/>
           <p:nvPr/>
         </p:nvSpPr>
         <p:spPr>
           <a:xfrm>
-            <a:off x="1783080" y="2542032"/>
-            <a:ext cx="2286000" cy="749808"/>
+            <a:off x="274320" y="1764792"/>
+            <a:ext cx="1389888" cy="749808"/>
           </a:xfrm>
-          <a:prstGeom prst="roundRect">
-            <a:avLst>
-              <a:gd name="adj" fmla="val 6000"/>
-            </a:avLst>
+          <a:prstGeom prst="rect">
+            <a:avLst/>
           </a:prstGeom>
-          <a:solidFill>
-            <a:srgbClr val="FFFFFF"/>
-          </a:solidFill>
-          <a:ln w="9525">
-            <a:solidFill>
-              <a:srgbClr val="D6DEE8"/>
-            </a:solidFill>
-          </a:ln>
-          <a:effectLst/>
+          <a:noFill/>
         </p:spPr>
-        <p:style>
-          <a:lnRef idx="1">
-            <a:schemeClr val="accent1"/>
-          </a:lnRef>
-          <a:fillRef idx="3">
-            <a:schemeClr val="accent1"/>
-          </a:fillRef>
-          <a:effectRef idx="2">
-            <a:schemeClr val="accent1"/>
-          </a:effectRef>
-          <a:fontRef idx="minor">
-            <a:schemeClr val="lt1"/>
-          </a:fontRef>
-        </p:style>
         <p:txBody>
-          <a:bodyPr rtlCol="0" anchor="ctr"/>
+          <a:bodyPr wrap="square" anchor="ctr" lIns="45720" rIns="36576" tIns="9144" bIns="9144">
+            <a:spAutoFit/>
+          </a:bodyPr>
           <a:lstStyle/>
           <a:p>
-            <a:pPr algn="ctr"/>
+            <a:pPr algn="l">
+              <a:lnSpc>
+                <a:spcPct val="100000"/>
+              </a:lnSpc>
+              <a:spcBef>
+                <a:spcPts val="0"/>
+              </a:spcBef>
+              <a:spcAft>
+                <a:spcPts val="150"/>
+              </a:spcAft>
+            </a:pPr>
+            <a:r>
+              <a:rPr b="1" sz="800">
+                <a:solidFill>
+                  <a:srgbClr val="111827"/>
+                </a:solidFill>
+                <a:latin typeface="Manrope"/>
+              </a:rPr>
+              <a:t>Improve demand fulfilment to 50%</a:t>
+            </a:r>
+          </a:p>
+          <a:p>
+            <a:pPr algn="l">
+              <a:lnSpc>
+                <a:spcPct val="100000"/>
+              </a:lnSpc>
+              <a:spcBef>
+                <a:spcPts val="0"/>
+              </a:spcBef>
+              <a:spcAft>
+                <a:spcPts val="150"/>
+              </a:spcAft>
+            </a:pPr>
+            <a:r>
+              <a:rPr b="0" sz="630">
+                <a:solidFill>
+                  <a:srgbClr val="5D6675"/>
+                </a:solidFill>
+                <a:latin typeface="Manrope"/>
+              </a:rPr>
+              <a:t>Matching, bid ranges &amp; real-time visibility</a:t>
+            </a:r>
+          </a:p>
+        </p:txBody>
+      </p:sp>
+      <p:sp>
+        <p:nvSpPr>
+          <p:cNvPr id="174" name="TextBox 173"/>
+          <p:cNvSpPr txBox="1"/>
+          <p:nvPr/>
+        </p:nvSpPr>
+        <p:spPr>
+          <a:xfrm>
+            <a:off x="1709928" y="1764792"/>
+            <a:ext cx="2103120" cy="749808"/>
+          </a:xfrm>
+          <a:prstGeom prst="rect">
+            <a:avLst/>
+          </a:prstGeom>
+          <a:noFill/>
+        </p:spPr>
+        <p:txBody>
+          <a:bodyPr wrap="square" anchor="ctr" lIns="45720" rIns="36576" tIns="9144" bIns="9144">
+            <a:spAutoFit/>
+          </a:bodyPr>
+          <a:lstStyle/>
+          <a:p>
+            <a:pPr algn="l">
+              <a:lnSpc>
+                <a:spcPct val="100000"/>
+              </a:lnSpc>
+              <a:spcBef>
+                <a:spcPts val="0"/>
+              </a:spcBef>
+              <a:spcAft>
+                <a:spcPts val="150"/>
+              </a:spcAft>
+            </a:pPr>
+            <a:r>
+              <a:rPr b="0" sz="650">
+                <a:solidFill>
+                  <a:srgbClr val="111827"/>
+                </a:solidFill>
+                <a:latin typeface="Manrope"/>
+              </a:rPr>
+              <a:t>• </a:t>
+            </a:r>
+            <a:r>
+              <a:rPr b="0" sz="650">
+                <a:solidFill>
+                  <a:srgbClr val="111827"/>
+                </a:solidFill>
+                <a:latin typeface="Manrope"/>
+              </a:rPr>
+              <a:t>Suggested bid ranges</a:t>
+            </a:r>
+          </a:p>
+          <a:p>
+            <a:pPr algn="l">
+              <a:lnSpc>
+                <a:spcPct val="100000"/>
+              </a:lnSpc>
+              <a:spcBef>
+                <a:spcPts val="0"/>
+              </a:spcBef>
+              <a:spcAft>
+                <a:spcPts val="150"/>
+              </a:spcAft>
+            </a:pPr>
+            <a:r>
+              <a:rPr b="0" sz="650">
+                <a:solidFill>
+                  <a:srgbClr val="111827"/>
+                </a:solidFill>
+                <a:latin typeface="Manrope"/>
+              </a:rPr>
+              <a:t>• </a:t>
+            </a:r>
+            <a:r>
+              <a:rPr b="0" sz="650">
+                <a:solidFill>
+                  <a:srgbClr val="111827"/>
+                </a:solidFill>
+                <a:latin typeface="Manrope"/>
+              </a:rPr>
+              <a:t>Real-time matching visibility</a:t>
+            </a:r>
+          </a:p>
+          <a:p>
+            <a:pPr algn="l">
+              <a:lnSpc>
+                <a:spcPct val="100000"/>
+              </a:lnSpc>
+              <a:spcBef>
+                <a:spcPts val="0"/>
+              </a:spcBef>
+              <a:spcAft>
+                <a:spcPts val="150"/>
+              </a:spcAft>
+            </a:pPr>
+            <a:r>
+              <a:rPr b="0" sz="650">
+                <a:solidFill>
+                  <a:srgbClr val="111827"/>
+                </a:solidFill>
+                <a:latin typeface="Manrope"/>
+              </a:rPr>
+              <a:t>• </a:t>
+            </a:r>
+            <a:r>
+              <a:rPr b="0" sz="650">
+                <a:solidFill>
+                  <a:srgbClr val="111827"/>
+                </a:solidFill>
+                <a:latin typeface="Manrope"/>
+              </a:rPr>
+              <a:t>FO–demand matching tuning</a:t>
+            </a:r>
+          </a:p>
+        </p:txBody>
+      </p:sp>
+      <p:pic>
+        <p:nvPicPr>
+          <p:cNvPr id="175" name="Picture 174" descr="c2_fulfil.png"/>
+          <p:cNvPicPr>
+            <a:picLocks noChangeAspect="1"/>
+          </p:cNvPicPr>
+          <p:nvPr/>
+        </p:nvPicPr>
+        <p:blipFill>
+          <a:blip r:embed="rId8"/>
+          <a:stretch>
+            <a:fillRect/>
+          </a:stretch>
+        </p:blipFill>
+        <p:spPr>
+          <a:xfrm>
+            <a:off x="3904487" y="1872325"/>
+            <a:ext cx="1572768" cy="534741"/>
+          </a:xfrm>
+          <a:prstGeom prst="rect">
+            <a:avLst/>
+          </a:prstGeom>
+        </p:spPr>
+      </p:pic>
+      <p:sp>
+        <p:nvSpPr>
+          <p:cNvPr id="176" name="TextBox 175"/>
+          <p:cNvSpPr txBox="1"/>
+          <p:nvPr/>
+        </p:nvSpPr>
+        <p:spPr>
+          <a:xfrm>
+            <a:off x="5522976" y="1764792"/>
+            <a:ext cx="1170432" cy="749808"/>
+          </a:xfrm>
+          <a:prstGeom prst="rect">
+            <a:avLst/>
+          </a:prstGeom>
+          <a:noFill/>
+        </p:spPr>
+        <p:txBody>
+          <a:bodyPr wrap="square" anchor="ctr" lIns="27432" rIns="27432" tIns="9144" bIns="9144">
+            <a:spAutoFit/>
+          </a:bodyPr>
+          <a:lstStyle/>
+          <a:p>
+            <a:pPr algn="l">
+              <a:lnSpc>
+                <a:spcPct val="100000"/>
+              </a:lnSpc>
+              <a:spcBef>
+                <a:spcPts val="0"/>
+              </a:spcBef>
+              <a:spcAft>
+                <a:spcPts val="150"/>
+              </a:spcAft>
+            </a:pPr>
+            <a:r>
+              <a:rPr b="0" sz="650">
+                <a:solidFill>
+                  <a:srgbClr val="111827"/>
+                </a:solidFill>
+                <a:latin typeface="Manrope"/>
+              </a:rPr>
+              <a:t>Placeable fulfil 31→</a:t>
+            </a:r>
+            <a:r>
+              <a:rPr b="1" sz="650">
+                <a:solidFill>
+                  <a:srgbClr val="1C6B2D"/>
+                </a:solidFill>
+                <a:latin typeface="Manrope"/>
+              </a:rPr>
+              <a:t>43.5%</a:t>
+            </a:r>
+          </a:p>
+          <a:p>
+            <a:pPr algn="l">
+              <a:lnSpc>
+                <a:spcPct val="100000"/>
+              </a:lnSpc>
+              <a:spcBef>
+                <a:spcPts val="0"/>
+              </a:spcBef>
+              <a:spcAft>
+                <a:spcPts val="150"/>
+              </a:spcAft>
+            </a:pPr>
+            <a:r>
+              <a:rPr b="0" sz="650">
+                <a:solidFill>
+                  <a:srgbClr val="111827"/>
+                </a:solidFill>
+                <a:latin typeface="Manrope"/>
+              </a:rPr>
+              <a:t>Bids 670→725</a:t>
+            </a:r>
+          </a:p>
+          <a:p>
+            <a:pPr algn="l">
+              <a:lnSpc>
+                <a:spcPct val="100000"/>
+              </a:lnSpc>
+              <a:spcBef>
+                <a:spcPts val="0"/>
+              </a:spcBef>
+              <a:spcAft>
+                <a:spcPts val="150"/>
+              </a:spcAft>
+            </a:pPr>
+            <a:r>
+              <a:rPr b="0" sz="650">
+                <a:solidFill>
+                  <a:srgbClr val="111827"/>
+                </a:solidFill>
+                <a:latin typeface="Manrope"/>
+              </a:rPr>
+              <a:t>Unique FOs 211→267</a:t>
+            </a:r>
+          </a:p>
+        </p:txBody>
+      </p:sp>
+      <p:sp>
+        <p:nvSpPr>
+          <p:cNvPr id="177" name="TextBox 176"/>
+          <p:cNvSpPr txBox="1"/>
+          <p:nvPr/>
+        </p:nvSpPr>
+        <p:spPr>
+          <a:xfrm>
+            <a:off x="6775704" y="1764792"/>
+            <a:ext cx="2075688" cy="749808"/>
+          </a:xfrm>
+          <a:prstGeom prst="rect">
+            <a:avLst/>
+          </a:prstGeom>
+          <a:noFill/>
+        </p:spPr>
+        <p:txBody>
+          <a:bodyPr wrap="square" anchor="ctr" lIns="45720" rIns="36576" tIns="9144" bIns="9144">
+            <a:spAutoFit/>
+          </a:bodyPr>
+          <a:lstStyle/>
+          <a:p>
+            <a:pPr algn="l">
+              <a:lnSpc>
+                <a:spcPct val="100000"/>
+              </a:lnSpc>
+              <a:spcBef>
+                <a:spcPts val="0"/>
+              </a:spcBef>
+              <a:spcAft>
+                <a:spcPts val="150"/>
+              </a:spcAft>
+            </a:pPr>
+            <a:r>
+              <a:rPr b="0" sz="650">
+                <a:solidFill>
+                  <a:srgbClr val="111827"/>
+                </a:solidFill>
+                <a:latin typeface="Manrope"/>
+              </a:rPr>
+              <a:t>• </a:t>
+            </a:r>
+            <a:r>
+              <a:rPr b="0" sz="650">
+                <a:solidFill>
+                  <a:srgbClr val="111827"/>
+                </a:solidFill>
+                <a:latin typeface="Manrope"/>
+              </a:rPr>
+              <a:t>Sustain 50% placeable-fulfilment target</a:t>
+            </a:r>
+          </a:p>
+          <a:p>
+            <a:pPr algn="l">
+              <a:lnSpc>
+                <a:spcPct val="100000"/>
+              </a:lnSpc>
+              <a:spcBef>
+                <a:spcPts val="0"/>
+              </a:spcBef>
+              <a:spcAft>
+                <a:spcPts val="150"/>
+              </a:spcAft>
+            </a:pPr>
+            <a:r>
+              <a:rPr b="0" sz="650">
+                <a:solidFill>
+                  <a:srgbClr val="111827"/>
+                </a:solidFill>
+                <a:latin typeface="Manrope"/>
+              </a:rPr>
+              <a:t>• </a:t>
+            </a:r>
+            <a:r>
+              <a:rPr b="0" sz="650">
+                <a:solidFill>
+                  <a:srgbClr val="111827"/>
+                </a:solidFill>
+                <a:latin typeface="Manrope"/>
+              </a:rPr>
+              <a:t>Bid ranges &amp; matching visibility</a:t>
+            </a:r>
+          </a:p>
+          <a:p>
+            <a:pPr algn="l">
+              <a:lnSpc>
+                <a:spcPct val="100000"/>
+              </a:lnSpc>
+              <a:spcBef>
+                <a:spcPts val="0"/>
+              </a:spcBef>
+              <a:spcAft>
+                <a:spcPts val="150"/>
+              </a:spcAft>
+            </a:pPr>
+            <a:r>
+              <a:rPr b="0" sz="650">
+                <a:solidFill>
+                  <a:srgbClr val="111827"/>
+                </a:solidFill>
+                <a:latin typeface="Manrope"/>
+              </a:rPr>
+              <a:t>• </a:t>
+            </a:r>
+            <a:r>
+              <a:rPr b="0" sz="650">
+                <a:solidFill>
+                  <a:srgbClr val="111827"/>
+                </a:solidFill>
+                <a:latin typeface="Manrope"/>
+              </a:rPr>
+              <a:t>Rebuild bid consistency across lanes</a:t>
+            </a:r>
           </a:p>
         </p:txBody>
       </p:sp>
@@ -14535,8 +14671,8 @@
         </p:nvSpPr>
         <p:spPr>
           <a:xfrm>
-            <a:off x="4114800" y="2542032"/>
-            <a:ext cx="2121408" cy="749808"/>
+            <a:off x="274320" y="2542032"/>
+            <a:ext cx="1389888" cy="749808"/>
           </a:xfrm>
           <a:prstGeom prst="roundRect">
             <a:avLst>
@@ -14583,8 +14719,8 @@
         </p:nvSpPr>
         <p:spPr>
           <a:xfrm>
-            <a:off x="6281928" y="2542032"/>
-            <a:ext cx="2569464" cy="749808"/>
+            <a:off x="1709928" y="2542032"/>
+            <a:ext cx="2103120" cy="749808"/>
           </a:xfrm>
           <a:prstGeom prst="roundRect">
             <a:avLst>
@@ -14625,14 +14761,110 @@
       </p:sp>
       <p:sp>
         <p:nvSpPr>
-          <p:cNvPr id="180" name="TextBox 179"/>
+          <p:cNvPr id="180" name="Rounded Rectangle 179"/>
+          <p:cNvSpPr/>
+          <p:nvPr/>
+        </p:nvSpPr>
+        <p:spPr>
+          <a:xfrm>
+            <a:off x="3858768" y="2542032"/>
+            <a:ext cx="2871216" cy="749808"/>
+          </a:xfrm>
+          <a:prstGeom prst="roundRect">
+            <a:avLst>
+              <a:gd name="adj" fmla="val 6000"/>
+            </a:avLst>
+          </a:prstGeom>
+          <a:solidFill>
+            <a:srgbClr val="FFFFFF"/>
+          </a:solidFill>
+          <a:ln w="9525">
+            <a:solidFill>
+              <a:srgbClr val="D6DEE8"/>
+            </a:solidFill>
+          </a:ln>
+          <a:effectLst/>
+        </p:spPr>
+        <p:style>
+          <a:lnRef idx="1">
+            <a:schemeClr val="accent1"/>
+          </a:lnRef>
+          <a:fillRef idx="3">
+            <a:schemeClr val="accent1"/>
+          </a:fillRef>
+          <a:effectRef idx="2">
+            <a:schemeClr val="accent1"/>
+          </a:effectRef>
+          <a:fontRef idx="minor">
+            <a:schemeClr val="lt1"/>
+          </a:fontRef>
+        </p:style>
+        <p:txBody>
+          <a:bodyPr rtlCol="0" anchor="ctr"/>
+          <a:lstStyle/>
+          <a:p>
+            <a:pPr algn="ctr"/>
+          </a:p>
+        </p:txBody>
+      </p:sp>
+      <p:sp>
+        <p:nvSpPr>
+          <p:cNvPr id="181" name="Rounded Rectangle 180"/>
+          <p:cNvSpPr/>
+          <p:nvPr/>
+        </p:nvSpPr>
+        <p:spPr>
+          <a:xfrm>
+            <a:off x="6775704" y="2542032"/>
+            <a:ext cx="2075688" cy="749808"/>
+          </a:xfrm>
+          <a:prstGeom prst="roundRect">
+            <a:avLst>
+              <a:gd name="adj" fmla="val 6000"/>
+            </a:avLst>
+          </a:prstGeom>
+          <a:solidFill>
+            <a:srgbClr val="FFFFFF"/>
+          </a:solidFill>
+          <a:ln w="9525">
+            <a:solidFill>
+              <a:srgbClr val="D6DEE8"/>
+            </a:solidFill>
+          </a:ln>
+          <a:effectLst/>
+        </p:spPr>
+        <p:style>
+          <a:lnRef idx="1">
+            <a:schemeClr val="accent1"/>
+          </a:lnRef>
+          <a:fillRef idx="3">
+            <a:schemeClr val="accent1"/>
+          </a:fillRef>
+          <a:effectRef idx="2">
+            <a:schemeClr val="accent1"/>
+          </a:effectRef>
+          <a:fontRef idx="minor">
+            <a:schemeClr val="lt1"/>
+          </a:fontRef>
+        </p:style>
+        <p:txBody>
+          <a:bodyPr rtlCol="0" anchor="ctr"/>
+          <a:lstStyle/>
+          <a:p>
+            <a:pPr algn="ctr"/>
+          </a:p>
+        </p:txBody>
+      </p:sp>
+      <p:sp>
+        <p:nvSpPr>
+          <p:cNvPr id="182" name="TextBox 181"/>
           <p:cNvSpPr txBox="1"/>
           <p:nvPr/>
         </p:nvSpPr>
         <p:spPr>
           <a:xfrm>
             <a:off x="274320" y="2542032"/>
-            <a:ext cx="1463040" cy="749808"/>
+            <a:ext cx="1389888" cy="749808"/>
           </a:xfrm>
           <a:prstGeom prst="rect">
             <a:avLst/>
@@ -14692,14 +14924,14 @@
       </p:sp>
       <p:sp>
         <p:nvSpPr>
-          <p:cNvPr id="181" name="TextBox 180"/>
+          <p:cNvPr id="183" name="TextBox 182"/>
           <p:cNvSpPr txBox="1"/>
           <p:nvPr/>
         </p:nvSpPr>
         <p:spPr>
           <a:xfrm>
-            <a:off x="1783080" y="2542032"/>
-            <a:ext cx="2286000" cy="749808"/>
+            <a:off x="1709928" y="2542032"/>
+            <a:ext cx="2103120" cy="749808"/>
           </a:xfrm>
           <a:prstGeom prst="rect">
             <a:avLst/>
@@ -14730,16 +14962,7 @@
                 </a:solidFill>
                 <a:latin typeface="Manrope"/>
               </a:rPr>
-              <a:t>AI inventory 728 → </a:t>
-            </a:r>
-            <a:r>
-              <a:rPr b="1" sz="650">
-                <a:solidFill>
-                  <a:srgbClr val="1C6B2D"/>
-                </a:solidFill>
-                <a:latin typeface="Manrope"/>
-              </a:rPr>
-              <a:t>1,043</a:t>
+              <a:t>• </a:t>
             </a:r>
             <a:r>
               <a:rPr b="0" sz="650">
@@ -14748,7 +14971,7 @@
                 </a:solidFill>
                 <a:latin typeface="Manrope"/>
               </a:rPr>
-              <a:t> (~65–77% of total)</a:t>
+              <a:t>Agentic calling for inventory (AI bot)</a:t>
             </a:r>
           </a:p>
           <a:p>
@@ -14770,16 +14993,7 @@
                 </a:solidFill>
                 <a:latin typeface="Manrope"/>
               </a:rPr>
-              <a:t>Manual inventory 1,098 → </a:t>
-            </a:r>
-            <a:r>
-              <a:rPr b="1" sz="650">
-                <a:solidFill>
-                  <a:srgbClr val="980000"/>
-                </a:solidFill>
-                <a:latin typeface="Manrope"/>
-              </a:rPr>
-              <a:t>472</a:t>
+              <a:t>• </a:t>
             </a:r>
             <a:r>
               <a:rPr b="0" sz="650">
@@ -14788,7 +15002,7 @@
                 </a:solidFill>
                 <a:latin typeface="Manrope"/>
               </a:rPr>
-              <a:t> (−57%)</a:t>
+              <a:t>Call → inventory automation</a:t>
             </a:r>
           </a:p>
           <a:p>
@@ -14810,14 +15024,23 @@
                 </a:solidFill>
                 <a:latin typeface="Manrope"/>
               </a:rPr>
-              <a:t>Agent calls scaled to 16k (May)</a:t>
+              <a:t>• </a:t>
+            </a:r>
+            <a:r>
+              <a:rPr b="0" sz="650">
+                <a:solidFill>
+                  <a:srgbClr val="111827"/>
+                </a:solidFill>
+                <a:latin typeface="Manrope"/>
+              </a:rPr>
+              <a:t>Manual-ops reduction</a:t>
             </a:r>
           </a:p>
         </p:txBody>
       </p:sp>
       <p:pic>
         <p:nvPicPr>
-          <p:cNvPr id="182" name="Picture 181" descr="c3_inv.png"/>
+          <p:cNvPr id="184" name="Picture 183" descr="c3_inv.png"/>
           <p:cNvPicPr>
             <a:picLocks noChangeAspect="1"/>
           </p:cNvPicPr>
@@ -14831,8 +15054,8 @@
         </p:blipFill>
         <p:spPr>
           <a:xfrm>
-            <a:off x="4178808" y="2578059"/>
-            <a:ext cx="1993392" cy="677753"/>
+            <a:off x="3904487" y="2649565"/>
+            <a:ext cx="1572768" cy="534741"/>
           </a:xfrm>
           <a:prstGeom prst="rect">
             <a:avLst/>
@@ -14841,14 +15064,121 @@
       </p:pic>
       <p:sp>
         <p:nvSpPr>
-          <p:cNvPr id="183" name="TextBox 182"/>
+          <p:cNvPr id="185" name="TextBox 184"/>
           <p:cNvSpPr txBox="1"/>
           <p:nvPr/>
         </p:nvSpPr>
         <p:spPr>
           <a:xfrm>
-            <a:off x="6281928" y="2542032"/>
-            <a:ext cx="2569464" cy="749808"/>
+            <a:off x="5522976" y="2542032"/>
+            <a:ext cx="1170432" cy="749808"/>
+          </a:xfrm>
+          <a:prstGeom prst="rect">
+            <a:avLst/>
+          </a:prstGeom>
+          <a:noFill/>
+        </p:spPr>
+        <p:txBody>
+          <a:bodyPr wrap="square" anchor="ctr" lIns="27432" rIns="27432" tIns="9144" bIns="9144">
+            <a:spAutoFit/>
+          </a:bodyPr>
+          <a:lstStyle/>
+          <a:p>
+            <a:pPr algn="l">
+              <a:lnSpc>
+                <a:spcPct val="100000"/>
+              </a:lnSpc>
+              <a:spcBef>
+                <a:spcPts val="0"/>
+              </a:spcBef>
+              <a:spcAft>
+                <a:spcPts val="150"/>
+              </a:spcAft>
+            </a:pPr>
+            <a:r>
+              <a:rPr b="0" sz="650">
+                <a:solidFill>
+                  <a:srgbClr val="111827"/>
+                </a:solidFill>
+                <a:latin typeface="Manrope"/>
+              </a:rPr>
+              <a:t>AI inv 728→</a:t>
+            </a:r>
+            <a:r>
+              <a:rPr b="1" sz="650">
+                <a:solidFill>
+                  <a:srgbClr val="1C6B2D"/>
+                </a:solidFill>
+                <a:latin typeface="Manrope"/>
+              </a:rPr>
+              <a:t>1,043</a:t>
+            </a:r>
+          </a:p>
+          <a:p>
+            <a:pPr algn="l">
+              <a:lnSpc>
+                <a:spcPct val="100000"/>
+              </a:lnSpc>
+              <a:spcBef>
+                <a:spcPts val="0"/>
+              </a:spcBef>
+              <a:spcAft>
+                <a:spcPts val="150"/>
+              </a:spcAft>
+            </a:pPr>
+            <a:r>
+              <a:rPr b="0" sz="650">
+                <a:solidFill>
+                  <a:srgbClr val="111827"/>
+                </a:solidFill>
+                <a:latin typeface="Manrope"/>
+              </a:rPr>
+              <a:t>Manual 1,098→</a:t>
+            </a:r>
+            <a:r>
+              <a:rPr b="1" sz="650">
+                <a:solidFill>
+                  <a:srgbClr val="980000"/>
+                </a:solidFill>
+                <a:latin typeface="Manrope"/>
+              </a:rPr>
+              <a:t>472</a:t>
+            </a:r>
+          </a:p>
+          <a:p>
+            <a:pPr algn="l">
+              <a:lnSpc>
+                <a:spcPct val="100000"/>
+              </a:lnSpc>
+              <a:spcBef>
+                <a:spcPts val="0"/>
+              </a:spcBef>
+              <a:spcAft>
+                <a:spcPts val="150"/>
+              </a:spcAft>
+            </a:pPr>
+            <a:r>
+              <a:rPr b="0" sz="650">
+                <a:solidFill>
+                  <a:srgbClr val="111827"/>
+                </a:solidFill>
+                <a:latin typeface="Manrope"/>
+              </a:rPr>
+              <a:t>Agent calls → 16k</a:t>
+            </a:r>
+          </a:p>
+        </p:txBody>
+      </p:sp>
+      <p:sp>
+        <p:nvSpPr>
+          <p:cNvPr id="186" name="TextBox 185"/>
+          <p:cNvSpPr txBox="1"/>
+          <p:nvPr/>
+        </p:nvSpPr>
+        <p:spPr>
+          <a:xfrm>
+            <a:off x="6775704" y="2542032"/>
+            <a:ext cx="2075688" cy="749808"/>
           </a:xfrm>
           <a:prstGeom prst="rect">
             <a:avLst/>
@@ -14888,7 +15218,7 @@
                 </a:solidFill>
                 <a:latin typeface="Manrope"/>
               </a:rPr>
-              <a:t>Inventory quality: best-time-to-call, power-lane proximity, FO filtering</a:t>
+              <a:t>Inventory quality: best-time-to-call, power-lane, FO filtering</a:t>
             </a:r>
           </a:p>
           <a:p>
@@ -14919,7 +15249,7 @@
                 </a:solidFill>
                 <a:latin typeface="Manrope"/>
               </a:rPr>
-              <a:t>Lift placeable conversion (23.9% → 11.4%)</a:t>
+              <a:t>Lift placeable conversion (23.9→11.4%)</a:t>
             </a:r>
           </a:p>
           <a:p>
@@ -14950,21 +15280,21 @@
                 </a:solidFill>
                 <a:latin typeface="Manrope"/>
               </a:rPr>
-              <a:t>Grow net inventory back to 1,500/mo</a:t>
+              <a:t>Grow net inventory to 1,500/mo</a:t>
             </a:r>
           </a:p>
         </p:txBody>
       </p:sp>
       <p:sp>
         <p:nvSpPr>
-          <p:cNvPr id="184" name="Rounded Rectangle 183"/>
+          <p:cNvPr id="187" name="Rounded Rectangle 186"/>
           <p:cNvSpPr/>
           <p:nvPr/>
         </p:nvSpPr>
         <p:spPr>
           <a:xfrm>
             <a:off x="274320" y="3319272"/>
-            <a:ext cx="1463040" cy="749808"/>
+            <a:ext cx="1389888" cy="749808"/>
           </a:xfrm>
           <a:prstGeom prst="roundRect">
             <a:avLst>
@@ -15005,14 +15335,14 @@
       </p:sp>
       <p:sp>
         <p:nvSpPr>
-          <p:cNvPr id="185" name="Rounded Rectangle 184"/>
+          <p:cNvPr id="188" name="Rounded Rectangle 187"/>
           <p:cNvSpPr/>
           <p:nvPr/>
         </p:nvSpPr>
         <p:spPr>
           <a:xfrm>
-            <a:off x="1783080" y="3319272"/>
-            <a:ext cx="2286000" cy="749808"/>
+            <a:off x="1709928" y="3319272"/>
+            <a:ext cx="2103120" cy="749808"/>
           </a:xfrm>
           <a:prstGeom prst="roundRect">
             <a:avLst>
@@ -15053,14 +15383,14 @@
       </p:sp>
       <p:sp>
         <p:nvSpPr>
-          <p:cNvPr id="186" name="Rounded Rectangle 185"/>
+          <p:cNvPr id="189" name="Rounded Rectangle 188"/>
           <p:cNvSpPr/>
           <p:nvPr/>
         </p:nvSpPr>
         <p:spPr>
           <a:xfrm>
-            <a:off x="4114800" y="3319272"/>
-            <a:ext cx="2121408" cy="749808"/>
+            <a:off x="3858768" y="3319272"/>
+            <a:ext cx="2871216" cy="749808"/>
           </a:xfrm>
           <a:prstGeom prst="roundRect">
             <a:avLst>
@@ -15101,14 +15431,14 @@
       </p:sp>
       <p:sp>
         <p:nvSpPr>
-          <p:cNvPr id="187" name="Rounded Rectangle 186"/>
+          <p:cNvPr id="190" name="Rounded Rectangle 189"/>
           <p:cNvSpPr/>
           <p:nvPr/>
         </p:nvSpPr>
         <p:spPr>
           <a:xfrm>
-            <a:off x="6281928" y="3319272"/>
-            <a:ext cx="2569464" cy="749808"/>
+            <a:off x="6775704" y="3319272"/>
+            <a:ext cx="2075688" cy="749808"/>
           </a:xfrm>
           <a:prstGeom prst="roundRect">
             <a:avLst>
@@ -15149,14 +15479,14 @@
       </p:sp>
       <p:sp>
         <p:nvSpPr>
-          <p:cNvPr id="188" name="TextBox 187"/>
+          <p:cNvPr id="191" name="TextBox 190"/>
           <p:cNvSpPr txBox="1"/>
           <p:nvPr/>
         </p:nvSpPr>
         <p:spPr>
           <a:xfrm>
             <a:off x="274320" y="3319272"/>
-            <a:ext cx="1463040" cy="749808"/>
+            <a:ext cx="1389888" cy="749808"/>
           </a:xfrm>
           <a:prstGeom prst="rect">
             <a:avLst/>
@@ -15216,14 +15546,14 @@
       </p:sp>
       <p:sp>
         <p:nvSpPr>
-          <p:cNvPr id="189" name="TextBox 188"/>
+          <p:cNvPr id="192" name="TextBox 191"/>
           <p:cNvSpPr txBox="1"/>
           <p:nvPr/>
         </p:nvSpPr>
         <p:spPr>
           <a:xfrm>
-            <a:off x="1783080" y="3319272"/>
-            <a:ext cx="2286000" cy="749808"/>
+            <a:off x="1709928" y="3319272"/>
+            <a:ext cx="2103120" cy="749808"/>
           </a:xfrm>
           <a:prstGeom prst="rect">
             <a:avLst/>
@@ -15254,7 +15584,16 @@
                 </a:solidFill>
                 <a:latin typeface="Manrope"/>
               </a:rPr>
-              <a:t>Automated Vahan verification &amp; journey updates in LSP WhatsApp</a:t>
+              <a:t>• </a:t>
+            </a:r>
+            <a:r>
+              <a:rPr b="0" sz="650">
+                <a:solidFill>
+                  <a:srgbClr val="111827"/>
+                </a:solidFill>
+                <a:latin typeface="Manrope"/>
+              </a:rPr>
+              <a:t>Automated Vahan verification (LSP WhatsApp)</a:t>
             </a:r>
           </a:p>
           <a:p>
@@ -15276,21 +15615,8 @@
                 </a:solidFill>
                 <a:latin typeface="Manrope"/>
               </a:rPr>
-              <a:t>Saves ~10 hrs City-Team effort daily</a:t>
+              <a:t>• </a:t>
             </a:r>
-          </a:p>
-          <a:p>
-            <a:pPr algn="l">
-              <a:lnSpc>
-                <a:spcPct val="100000"/>
-              </a:lnSpc>
-              <a:spcBef>
-                <a:spcPts val="0"/>
-              </a:spcBef>
-              <a:spcAft>
-                <a:spcPts val="150"/>
-              </a:spcAft>
-            </a:pPr>
             <a:r>
               <a:rPr b="0" sz="650">
                 <a:solidFill>
@@ -15298,14 +15624,14 @@
                 </a:solidFill>
                 <a:latin typeface="Manrope"/>
               </a:rPr>
-              <a:t>~15% CT resource-cost reduction</a:t>
+              <a:t>Automated journey/transit updates</a:t>
             </a:r>
           </a:p>
         </p:txBody>
       </p:sp>
       <p:pic>
         <p:nvPicPr>
-          <p:cNvPr id="190" name="Picture 189" descr="c4_calls.png"/>
+          <p:cNvPr id="193" name="Picture 192" descr="c4_calls.png"/>
           <p:cNvPicPr>
             <a:picLocks noChangeAspect="1"/>
           </p:cNvPicPr>
@@ -15319,8 +15645,8 @@
         </p:blipFill>
         <p:spPr>
           <a:xfrm>
-            <a:off x="4178808" y="3355299"/>
-            <a:ext cx="1993392" cy="677753"/>
+            <a:off x="3904487" y="3426805"/>
+            <a:ext cx="1572768" cy="534741"/>
           </a:xfrm>
           <a:prstGeom prst="rect">
             <a:avLst/>
@@ -15329,14 +15655,103 @@
       </p:pic>
       <p:sp>
         <p:nvSpPr>
-          <p:cNvPr id="191" name="TextBox 190"/>
+          <p:cNvPr id="194" name="TextBox 193"/>
           <p:cNvSpPr txBox="1"/>
           <p:nvPr/>
         </p:nvSpPr>
         <p:spPr>
           <a:xfrm>
-            <a:off x="6281928" y="3319272"/>
-            <a:ext cx="2569464" cy="749808"/>
+            <a:off x="5522976" y="3319272"/>
+            <a:ext cx="1170432" cy="749808"/>
+          </a:xfrm>
+          <a:prstGeom prst="rect">
+            <a:avLst/>
+          </a:prstGeom>
+          <a:noFill/>
+        </p:spPr>
+        <p:txBody>
+          <a:bodyPr wrap="square" anchor="ctr" lIns="27432" rIns="27432" tIns="9144" bIns="9144">
+            <a:spAutoFit/>
+          </a:bodyPr>
+          <a:lstStyle/>
+          <a:p>
+            <a:pPr algn="l">
+              <a:lnSpc>
+                <a:spcPct val="100000"/>
+              </a:lnSpc>
+              <a:spcBef>
+                <a:spcPts val="0"/>
+              </a:spcBef>
+              <a:spcAft>
+                <a:spcPts val="150"/>
+              </a:spcAft>
+            </a:pPr>
+            <a:r>
+              <a:rPr b="0" sz="650">
+                <a:solidFill>
+                  <a:srgbClr val="111827"/>
+                </a:solidFill>
+                <a:latin typeface="Manrope"/>
+              </a:rPr>
+              <a:t>~10 hrs/day CT effort saved</a:t>
+            </a:r>
+          </a:p>
+          <a:p>
+            <a:pPr algn="l">
+              <a:lnSpc>
+                <a:spcPct val="100000"/>
+              </a:lnSpc>
+              <a:spcBef>
+                <a:spcPts val="0"/>
+              </a:spcBef>
+              <a:spcAft>
+                <a:spcPts val="150"/>
+              </a:spcAft>
+            </a:pPr>
+            <a:r>
+              <a:rPr b="0" sz="650">
+                <a:solidFill>
+                  <a:srgbClr val="111827"/>
+                </a:solidFill>
+                <a:latin typeface="Manrope"/>
+              </a:rPr>
+              <a:t>~15% CT resource-cost cut</a:t>
+            </a:r>
+          </a:p>
+          <a:p>
+            <a:pPr algn="l">
+              <a:lnSpc>
+                <a:spcPct val="100000"/>
+              </a:lnSpc>
+              <a:spcBef>
+                <a:spcPts val="0"/>
+              </a:spcBef>
+              <a:spcAft>
+                <a:spcPts val="150"/>
+              </a:spcAft>
+            </a:pPr>
+            <a:r>
+              <a:rPr b="0" sz="650">
+                <a:solidFill>
+                  <a:srgbClr val="111827"/>
+                </a:solidFill>
+                <a:latin typeface="Manrope"/>
+              </a:rPr>
+              <a:t>Agent calls 12k→16k (peak)</a:t>
+            </a:r>
+          </a:p>
+        </p:txBody>
+      </p:sp>
+      <p:sp>
+        <p:nvSpPr>
+          <p:cNvPr id="195" name="TextBox 194"/>
+          <p:cNvSpPr txBox="1"/>
+          <p:nvPr/>
+        </p:nvSpPr>
+        <p:spPr>
+          <a:xfrm>
+            <a:off x="6775704" y="3319272"/>
+            <a:ext cx="2075688" cy="749808"/>
           </a:xfrm>
           <a:prstGeom prst="rect">
             <a:avLst/>
@@ -15376,7 +15791,7 @@
                 </a:solidFill>
                 <a:latin typeface="Manrope"/>
               </a:rPr>
-              <a:t>FO doc collection via app payment incentives</a:t>
+              <a:t>FO doc collection via app incentives</a:t>
             </a:r>
           </a:p>
           <a:p>
@@ -15445,14 +15860,14 @@
       </p:sp>
       <p:sp>
         <p:nvSpPr>
-          <p:cNvPr id="192" name="Rounded Rectangle 191"/>
+          <p:cNvPr id="196" name="Rounded Rectangle 195"/>
           <p:cNvSpPr/>
           <p:nvPr/>
         </p:nvSpPr>
         <p:spPr>
           <a:xfrm>
             <a:off x="274320" y="4096512"/>
-            <a:ext cx="1463040" cy="548640"/>
+            <a:ext cx="1389888" cy="548640"/>
           </a:xfrm>
           <a:prstGeom prst="roundRect">
             <a:avLst>
@@ -15493,14 +15908,14 @@
       </p:sp>
       <p:sp>
         <p:nvSpPr>
-          <p:cNvPr id="193" name="Rounded Rectangle 192"/>
+          <p:cNvPr id="197" name="Rounded Rectangle 196"/>
           <p:cNvSpPr/>
           <p:nvPr/>
         </p:nvSpPr>
         <p:spPr>
           <a:xfrm>
-            <a:off x="1783080" y="4096512"/>
-            <a:ext cx="2286000" cy="548640"/>
+            <a:off x="1709928" y="4096512"/>
+            <a:ext cx="2103120" cy="548640"/>
           </a:xfrm>
           <a:prstGeom prst="roundRect">
             <a:avLst>
@@ -15541,14 +15956,14 @@
       </p:sp>
       <p:sp>
         <p:nvSpPr>
-          <p:cNvPr id="194" name="Rounded Rectangle 193"/>
+          <p:cNvPr id="198" name="Rounded Rectangle 197"/>
           <p:cNvSpPr/>
           <p:nvPr/>
         </p:nvSpPr>
         <p:spPr>
           <a:xfrm>
-            <a:off x="4114800" y="4096512"/>
-            <a:ext cx="2121408" cy="548640"/>
+            <a:off x="3858768" y="4096512"/>
+            <a:ext cx="2871216" cy="548640"/>
           </a:xfrm>
           <a:prstGeom prst="roundRect">
             <a:avLst>
@@ -15589,14 +16004,14 @@
       </p:sp>
       <p:sp>
         <p:nvSpPr>
-          <p:cNvPr id="195" name="Rounded Rectangle 194"/>
+          <p:cNvPr id="199" name="Rounded Rectangle 198"/>
           <p:cNvSpPr/>
           <p:nvPr/>
         </p:nvSpPr>
         <p:spPr>
           <a:xfrm>
-            <a:off x="6281928" y="4096512"/>
-            <a:ext cx="2569464" cy="548640"/>
+            <a:off x="6775704" y="4096512"/>
+            <a:ext cx="2075688" cy="548640"/>
           </a:xfrm>
           <a:prstGeom prst="roundRect">
             <a:avLst>
@@ -15637,14 +16052,14 @@
       </p:sp>
       <p:sp>
         <p:nvSpPr>
-          <p:cNvPr id="196" name="TextBox 195"/>
+          <p:cNvPr id="200" name="TextBox 199"/>
           <p:cNvSpPr txBox="1"/>
           <p:nvPr/>
         </p:nvSpPr>
         <p:spPr>
           <a:xfrm>
             <a:off x="274320" y="4096512"/>
-            <a:ext cx="1463040" cy="548640"/>
+            <a:ext cx="1389888" cy="548640"/>
           </a:xfrm>
           <a:prstGeom prst="rect">
             <a:avLst/>
@@ -15704,14 +16119,14 @@
       </p:sp>
       <p:sp>
         <p:nvSpPr>
-          <p:cNvPr id="197" name="TextBox 196"/>
+          <p:cNvPr id="201" name="TextBox 200"/>
           <p:cNvSpPr txBox="1"/>
           <p:nvPr/>
         </p:nvSpPr>
         <p:spPr>
           <a:xfrm>
-            <a:off x="1783080" y="4096512"/>
-            <a:ext cx="2286000" cy="548640"/>
+            <a:off x="1709928" y="4096512"/>
+            <a:ext cx="2103120" cy="548640"/>
           </a:xfrm>
           <a:prstGeom prst="rect">
             <a:avLst/>
@@ -15742,20 +16157,29 @@
                 </a:solidFill>
                 <a:latin typeface="Manrope"/>
               </a:rPr>
-              <a:t>Initiative picked in June</a:t>
+              <a:t>• </a:t>
+            </a:r>
+            <a:r>
+              <a:rPr b="0" sz="650">
+                <a:solidFill>
+                  <a:srgbClr val="111827"/>
+                </a:solidFill>
+                <a:latin typeface="Manrope"/>
+              </a:rPr>
+              <a:t>Trip &amp; party-level ledger — kickoff</a:t>
             </a:r>
           </a:p>
         </p:txBody>
       </p:sp>
       <p:sp>
         <p:nvSpPr>
-          <p:cNvPr id="198" name="Rounded Rectangle 197"/>
+          <p:cNvPr id="202" name="Rounded Rectangle 201"/>
           <p:cNvSpPr/>
           <p:nvPr/>
         </p:nvSpPr>
         <p:spPr>
           <a:xfrm>
-            <a:off x="4672584" y="4251960"/>
+            <a:off x="4791456" y="4251960"/>
             <a:ext cx="1005840" cy="237744"/>
           </a:xfrm>
           <a:prstGeom prst="roundRect">
@@ -15795,13 +16219,13 @@
       </p:sp>
       <p:sp>
         <p:nvSpPr>
-          <p:cNvPr id="199" name="TextBox 198"/>
+          <p:cNvPr id="203" name="TextBox 202"/>
           <p:cNvSpPr txBox="1"/>
           <p:nvPr/>
         </p:nvSpPr>
         <p:spPr>
           <a:xfrm>
-            <a:off x="4672584" y="4251960"/>
+            <a:off x="4791456" y="4251960"/>
             <a:ext cx="1005840" cy="237744"/>
           </a:xfrm>
           <a:prstGeom prst="rect">
@@ -15840,14 +16264,14 @@
       </p:sp>
       <p:sp>
         <p:nvSpPr>
-          <p:cNvPr id="200" name="TextBox 199"/>
+          <p:cNvPr id="204" name="TextBox 203"/>
           <p:cNvSpPr txBox="1"/>
           <p:nvPr/>
         </p:nvSpPr>
         <p:spPr>
           <a:xfrm>
-            <a:off x="6281928" y="4096512"/>
-            <a:ext cx="2569464" cy="548640"/>
+            <a:off x="6775704" y="4096512"/>
+            <a:ext cx="2075688" cy="548640"/>
           </a:xfrm>
           <a:prstGeom prst="rect">
             <a:avLst/>
@@ -15925,14 +16349,14 @@
       </p:sp>
       <p:sp>
         <p:nvSpPr>
-          <p:cNvPr id="201" name="TextBox 200"/>
+          <p:cNvPr id="205" name="TextBox 204"/>
           <p:cNvSpPr txBox="1"/>
           <p:nvPr/>
         </p:nvSpPr>
         <p:spPr>
           <a:xfrm>
             <a:off x="274320" y="4828032"/>
-            <a:ext cx="5943600" cy="182880"/>
+            <a:ext cx="6949440" cy="182880"/>
           </a:xfrm>
           <a:prstGeom prst="rect">
             <a:avLst/>
@@ -15963,7 +16387,7 @@
                 </a:solidFill>
                 <a:latin typeface="Manrope"/>
               </a:rPr>
-              <a:t>Trend from monthly metrics (Jan–Jun'26); Apr–Jun highlighted. Delivered &amp; Next Focus per product roadmap.</a:t>
+              <a:t>Trend from monthly metrics (Jan–Jun'26); Apr–Jun highlighted. Feature names indicative — confirm against Linear delivered stories / roadmap.</a:t>
             </a:r>
           </a:p>
         </p:txBody>

</xml_diff>